<commit_message>
fixed updating node counts on load
</commit_message>
<xml_diff>
--- a/other/MSposter.pptx
+++ b/other/MSposter.pptx
@@ -7129,7 +7129,7 @@
           <p:nvPr>
             <p:extLst>
               <p:ext uri="{D42A27DB-BD31-4B8C-83A1-F6EECF244321}">
-                <p14:modId xmlns:p14="http://schemas.microsoft.com/office/powerpoint/2010/main" val="1771149354"/>
+                <p14:modId xmlns:p14="http://schemas.microsoft.com/office/powerpoint/2010/main" val="997556569"/>
               </p:ext>
             </p:extLst>
           </p:nvPr>
@@ -9254,7 +9254,7 @@
                           </a:solidFill>
                           <a:latin typeface="Libre Baskerville" panose="02000000000000000000" pitchFamily="2" charset="0"/>
                         </a:rPr>
-                        <a:t>O(V+E)</a:t>
+                        <a:t>O(V+8E)</a:t>
                       </a:r>
                     </a:p>
                   </a:txBody>

</xml_diff>